<commit_message>
Use steps instead of seconds for subscriber
</commit_message>
<xml_diff>
--- a/DaprPubSub.pptx
+++ b/DaprPubSub.pptx
@@ -6,8 +6,9 @@
   </p:sldMasterIdLst>
   <p:sldIdLst>
     <p:sldId id="256" r:id="rId2"/>
-    <p:sldId id="257" r:id="rId3"/>
-    <p:sldId id="258" r:id="rId4"/>
+    <p:sldId id="259" r:id="rId3"/>
+    <p:sldId id="257" r:id="rId4"/>
+    <p:sldId id="258" r:id="rId5"/>
   </p:sldIdLst>
   <p:sldSz cx="12192000" cy="6858000"/>
   <p:notesSz cx="6858000" cy="9144000"/>
@@ -106,6 +107,11 @@
       </a:defRPr>
     </a:lvl9pPr>
   </p:defaultTextStyle>
+  <p:extLst>
+    <p:ext uri="{EFAFB233-063F-42B5-8137-9DF3F51BA10A}">
+      <p15:sldGuideLst xmlns:p15="http://schemas.microsoft.com/office/powerpoint/2012/main"/>
+    </p:ext>
+  </p:extLst>
 </p:presentation>
 </file>
 
@@ -3366,7 +3372,7 @@
         </p:nvSpPr>
         <p:spPr>
           <a:xfrm>
-            <a:off x="635000" y="635000"/>
+            <a:off x="635000" y="104577"/>
             <a:ext cx="10922000" cy="615553"/>
           </a:xfrm>
           <a:prstGeom prst="rect">
@@ -3410,7 +3416,7 @@
         </p:nvCxnSpPr>
         <p:spPr>
           <a:xfrm>
-            <a:off x="635000" y="1803400"/>
+            <a:off x="543560" y="1090168"/>
             <a:ext cx="10922000" cy="0"/>
           </a:xfrm>
           <a:prstGeom prst="line">
@@ -3451,7 +3457,7 @@
         </p:nvSpPr>
         <p:spPr>
           <a:xfrm>
-            <a:off x="635000" y="1524000"/>
+            <a:off x="543560" y="690264"/>
             <a:ext cx="10922000" cy="307777"/>
           </a:xfrm>
           <a:prstGeom prst="rect">
@@ -3495,7 +3501,7 @@
         </p:nvSpPr>
         <p:spPr>
           <a:xfrm>
-            <a:off x="762000" y="2082800"/>
+            <a:off x="635000" y="1182296"/>
             <a:ext cx="10795000" cy="312906"/>
           </a:xfrm>
           <a:prstGeom prst="rect">
@@ -3510,7 +3516,7 @@
           <a:lstStyle/>
           <a:p>
             <a:r>
-              <a:rPr lang="nb-NO" sz="1400" b="1">
+              <a:rPr lang="nb-NO" sz="1400" b="1" dirty="0">
                 <a:solidFill>
                   <a:srgbClr val="146DFF"/>
                 </a:solidFill>
@@ -3518,14 +3524,30 @@
               <a:t>▸  Sidecar pattern   </a:t>
             </a:r>
             <a:r>
-              <a:rPr lang="en-US" sz="1300">
+              <a:rPr lang="en-US" sz="1300" dirty="0">
                 <a:solidFill>
                   <a:srgbClr val="DCE1EB"/>
                 </a:solidFill>
               </a:rPr>
-              <a:t>Your service calls localhost; Dapr handles brokers, retries, secrets — no library imports required</a:t>
-            </a:r>
-            <a:endParaRPr lang="ru-RU" sz="1300">
+              <a:t>Your service calls localhost; </a:t>
+            </a:r>
+            <a:r>
+              <a:rPr lang="en-US" sz="1300" dirty="0" err="1">
+                <a:solidFill>
+                  <a:srgbClr val="DCE1EB"/>
+                </a:solidFill>
+              </a:rPr>
+              <a:t>Dapr</a:t>
+            </a:r>
+            <a:r>
+              <a:rPr lang="en-US" sz="1300" dirty="0">
+                <a:solidFill>
+                  <a:srgbClr val="DCE1EB"/>
+                </a:solidFill>
+              </a:rPr>
+              <a:t> handles brokers, retries, secrets — no library imports required</a:t>
+            </a:r>
+            <a:endParaRPr lang="ru-RU" sz="1300" dirty="0">
               <a:solidFill>
                 <a:srgbClr val="DCE1EB"/>
               </a:solidFill>
@@ -3547,7 +3569,7 @@
         </p:nvSpPr>
         <p:spPr>
           <a:xfrm>
-            <a:off x="762000" y="2667000"/>
+            <a:off x="635000" y="1401668"/>
             <a:ext cx="10795000" cy="312906"/>
           </a:xfrm>
           <a:prstGeom prst="rect">
@@ -3562,7 +3584,7 @@
           <a:lstStyle/>
           <a:p>
             <a:r>
-              <a:rPr lang="nb-NO" sz="1400" b="1">
+              <a:rPr lang="nb-NO" sz="1400" b="1" dirty="0">
                 <a:solidFill>
                   <a:srgbClr val="146DFF"/>
                 </a:solidFill>
@@ -3570,14 +3592,14 @@
               <a:t>▸  10 building blocks   </a:t>
             </a:r>
             <a:r>
-              <a:rPr lang="en-US" sz="1300">
+              <a:rPr lang="en-US" sz="1300" dirty="0">
                 <a:solidFill>
                   <a:srgbClr val="DCE1EB"/>
                 </a:solidFill>
               </a:rPr>
               <a:t>Pub/Sub, Service Invocation, State, Actors, Workflows, Bindings, Secrets, Config, Lock, Crypto</a:t>
             </a:r>
-            <a:endParaRPr lang="ru-RU" sz="1300">
+            <a:endParaRPr lang="ru-RU" sz="1300" dirty="0">
               <a:solidFill>
                 <a:srgbClr val="DCE1EB"/>
               </a:solidFill>
@@ -3599,7 +3621,7 @@
         </p:nvSpPr>
         <p:spPr>
           <a:xfrm>
-            <a:off x="762000" y="3251200"/>
+            <a:off x="635000" y="1643225"/>
             <a:ext cx="10795000" cy="312906"/>
           </a:xfrm>
           <a:prstGeom prst="rect">
@@ -3614,7 +3636,7 @@
           <a:lstStyle/>
           <a:p>
             <a:r>
-              <a:rPr lang="nb-NO" sz="1400" b="1">
+              <a:rPr lang="nb-NO" sz="1400" b="1" dirty="0">
                 <a:solidFill>
                   <a:srgbClr val="146DFF"/>
                 </a:solidFill>
@@ -3622,14 +3644,14 @@
               <a:t>▸  Pluggable components   </a:t>
             </a:r>
             <a:r>
-              <a:rPr lang="en-US" sz="1300">
+              <a:rPr lang="en-US" sz="1300" dirty="0">
                 <a:solidFill>
                   <a:srgbClr val="DCE1EB"/>
                 </a:solidFill>
               </a:rPr>
               <a:t>Switch from Azure Service Bus to Kafka or RabbitMQ by editing one YAML file — zero code change</a:t>
             </a:r>
-            <a:endParaRPr lang="ru-RU" sz="1300">
+            <a:endParaRPr lang="ru-RU" sz="1300" dirty="0">
               <a:solidFill>
                 <a:srgbClr val="DCE1EB"/>
               </a:solidFill>
@@ -3651,7 +3673,7 @@
         </p:nvSpPr>
         <p:spPr>
           <a:xfrm>
-            <a:off x="762000" y="3835400"/>
+            <a:off x="635000" y="1925174"/>
             <a:ext cx="10795000" cy="312906"/>
           </a:xfrm>
           <a:prstGeom prst="rect">
@@ -3666,7 +3688,7 @@
           <a:lstStyle/>
           <a:p>
             <a:r>
-              <a:rPr lang="nb-NO" sz="1400" b="1">
+              <a:rPr lang="nb-NO" sz="1400" b="1" dirty="0">
                 <a:solidFill>
                   <a:srgbClr val="146DFF"/>
                 </a:solidFill>
@@ -3674,14 +3696,30 @@
               <a:t>▸  Built-in resiliency   </a:t>
             </a:r>
             <a:r>
-              <a:rPr lang="en-US" sz="1300">
+              <a:rPr lang="en-US" sz="1300" dirty="0">
                 <a:solidFill>
                   <a:srgbClr val="DCE1EB"/>
                 </a:solidFill>
               </a:rPr>
-              <a:t>Retries, timeouts, circuit breakers declared in resiliency.yaml — not scattered through application code</a:t>
-            </a:r>
-            <a:endParaRPr lang="ru-RU" sz="1300">
+              <a:t>Retries, timeouts, circuit breakers declared in </a:t>
+            </a:r>
+            <a:r>
+              <a:rPr lang="en-US" sz="1300" dirty="0" err="1">
+                <a:solidFill>
+                  <a:srgbClr val="DCE1EB"/>
+                </a:solidFill>
+              </a:rPr>
+              <a:t>resiliency.yaml</a:t>
+            </a:r>
+            <a:r>
+              <a:rPr lang="en-US" sz="1300" dirty="0">
+                <a:solidFill>
+                  <a:srgbClr val="DCE1EB"/>
+                </a:solidFill>
+              </a:rPr>
+              <a:t> — not scattered through application code</a:t>
+            </a:r>
+            <a:endParaRPr lang="ru-RU" sz="1300" dirty="0">
               <a:solidFill>
                 <a:srgbClr val="DCE1EB"/>
               </a:solidFill>
@@ -3703,7 +3741,7 @@
         </p:nvSpPr>
         <p:spPr>
           <a:xfrm>
-            <a:off x="762000" y="4419600"/>
+            <a:off x="635000" y="2180373"/>
             <a:ext cx="10795000" cy="312906"/>
           </a:xfrm>
           <a:prstGeom prst="rect">
@@ -3718,7 +3756,7 @@
           <a:lstStyle/>
           <a:p>
             <a:r>
-              <a:rPr lang="nb-NO" sz="1400" b="1">
+              <a:rPr lang="nb-NO" sz="1400" b="1" dirty="0">
                 <a:solidFill>
                   <a:srgbClr val="146DFF"/>
                 </a:solidFill>
@@ -3726,14 +3764,30 @@
               <a:t>▸  Observability   </a:t>
             </a:r>
             <a:r>
-              <a:rPr lang="en-US" sz="1300">
+              <a:rPr lang="en-US" sz="1300" dirty="0">
                 <a:solidFill>
                   <a:srgbClr val="DCE1EB"/>
                 </a:solidFill>
               </a:rPr>
-              <a:t>W3C distributed tracing, Prometheus metrics, structured logs via OpenTelemetry — automatic propagation</a:t>
-            </a:r>
-            <a:endParaRPr lang="ru-RU" sz="1300">
+              <a:t>W3C distributed tracing, Prometheus metrics, structured logs via </a:t>
+            </a:r>
+            <a:r>
+              <a:rPr lang="en-US" sz="1300" dirty="0" err="1">
+                <a:solidFill>
+                  <a:srgbClr val="DCE1EB"/>
+                </a:solidFill>
+              </a:rPr>
+              <a:t>OpenTelemetry</a:t>
+            </a:r>
+            <a:r>
+              <a:rPr lang="en-US" sz="1300" dirty="0">
+                <a:solidFill>
+                  <a:srgbClr val="DCE1EB"/>
+                </a:solidFill>
+              </a:rPr>
+              <a:t> — automatic propagation</a:t>
+            </a:r>
+            <a:endParaRPr lang="ru-RU" sz="1300" dirty="0">
               <a:solidFill>
                 <a:srgbClr val="DCE1EB"/>
               </a:solidFill>
@@ -3741,6 +3795,53 @@
           </a:p>
         </p:txBody>
       </p:sp>
+      <p:pic>
+        <p:nvPicPr>
+          <p:cNvPr id="1026" name="Picture 2">
+            <a:extLst>
+              <a:ext uri="{FF2B5EF4-FFF2-40B4-BE49-F238E27FC236}">
+                <a16:creationId xmlns:a16="http://schemas.microsoft.com/office/drawing/2014/main" id="{2B722F00-C65B-C8F0-A666-116D79336738}"/>
+              </a:ext>
+            </a:extLst>
+          </p:cNvPr>
+          <p:cNvPicPr>
+            <a:picLocks noChangeAspect="1" noChangeArrowheads="1"/>
+          </p:cNvPicPr>
+          <p:nvPr/>
+        </p:nvPicPr>
+        <p:blipFill>
+          <a:blip r:embed="rId2">
+            <a:extLst>
+              <a:ext uri="{28A0092B-C50C-407E-A947-70E740481C1C}">
+                <a14:useLocalDpi xmlns:a14="http://schemas.microsoft.com/office/drawing/2010/main" val="0"/>
+              </a:ext>
+            </a:extLst>
+          </a:blip>
+          <a:srcRect/>
+          <a:stretch>
+            <a:fillRect/>
+          </a:stretch>
+        </p:blipFill>
+        <p:spPr bwMode="auto">
+          <a:xfrm>
+            <a:off x="1563624" y="2501455"/>
+            <a:ext cx="7744968" cy="4356545"/>
+          </a:xfrm>
+          <a:prstGeom prst="rect">
+            <a:avLst/>
+          </a:prstGeom>
+          <a:noFill/>
+          <a:extLst>
+            <a:ext uri="{909E8E84-426E-40DD-AFC4-6F175D3DCCD1}">
+              <a14:hiddenFill xmlns:a14="http://schemas.microsoft.com/office/drawing/2010/main">
+                <a:solidFill>
+                  <a:srgbClr val="FFFFFF"/>
+                </a:solidFill>
+              </a14:hiddenFill>
+            </a:ext>
+          </a:extLst>
+        </p:spPr>
+      </p:pic>
     </p:spTree>
     <p:extLst>
       <p:ext uri="{BB962C8B-B14F-4D97-AF65-F5344CB8AC3E}">
@@ -3755,6 +3856,365 @@
 </file>
 
 <file path=ppt/slides/slide2.xml><?xml version="1.0" encoding="utf-8"?>
+<p:sld xmlns:a="http://schemas.openxmlformats.org/drawingml/2006/main" xmlns:r="http://schemas.openxmlformats.org/officeDocument/2006/relationships" xmlns:p="http://schemas.openxmlformats.org/presentationml/2006/main">
+  <p:cSld>
+    <p:spTree>
+      <p:nvGrpSpPr>
+        <p:cNvPr id="1" name=""/>
+        <p:cNvGrpSpPr/>
+        <p:nvPr/>
+      </p:nvGrpSpPr>
+      <p:grpSpPr>
+        <a:xfrm>
+          <a:off x="0" y="0"/>
+          <a:ext cx="0" cy="0"/>
+          <a:chOff x="0" y="0"/>
+          <a:chExt cx="0" cy="0"/>
+        </a:xfrm>
+      </p:grpSpPr>
+      <p:sp>
+        <p:nvSpPr>
+          <p:cNvPr id="3" name="TextBox 2">
+            <a:extLst>
+              <a:ext uri="{FF2B5EF4-FFF2-40B4-BE49-F238E27FC236}">
+                <a16:creationId xmlns:a16="http://schemas.microsoft.com/office/drawing/2014/main" id="{25B48D5F-1246-D446-A0AE-8545C0A7A8DB}"/>
+              </a:ext>
+            </a:extLst>
+          </p:cNvPr>
+          <p:cNvSpPr txBox="1"/>
+          <p:nvPr/>
+        </p:nvSpPr>
+        <p:spPr>
+          <a:xfrm>
+            <a:off x="2324862" y="529852"/>
+            <a:ext cx="6094476" cy="4832092"/>
+          </a:xfrm>
+          <a:prstGeom prst="rect">
+            <a:avLst/>
+          </a:prstGeom>
+          <a:noFill/>
+        </p:spPr>
+        <p:txBody>
+          <a:bodyPr wrap="square">
+            <a:spAutoFit/>
+          </a:bodyPr>
+          <a:lstStyle/>
+          <a:p>
+            <a:pPr>
+              <a:buNone/>
+            </a:pPr>
+            <a:r>
+              <a:rPr lang="en-US" sz="1100" dirty="0"/>
+              <a:t>1. Vendor and Broker Portability</a:t>
+            </a:r>
+          </a:p>
+          <a:p>
+            <a:pPr>
+              <a:buNone/>
+            </a:pPr>
+            <a:r>
+              <a:rPr lang="en-US" sz="1100" dirty="0" err="1"/>
+              <a:t>Dapr</a:t>
+            </a:r>
+            <a:r>
+              <a:rPr lang="en-US" sz="1100" dirty="0"/>
+              <a:t> abstracts the underlying message broker behind a consistent API. This allows you to swap brokers (e.g., using </a:t>
+            </a:r>
+            <a:r>
+              <a:rPr lang="en-US" sz="1100" b="1" dirty="0"/>
+              <a:t>Redis Streams</a:t>
+            </a:r>
+            <a:r>
+              <a:rPr lang="en-US" sz="1100" dirty="0"/>
+              <a:t> for local development and </a:t>
+            </a:r>
+            <a:r>
+              <a:rPr lang="en-US" sz="1100" b="1" dirty="0"/>
+              <a:t>Azure Service Bus</a:t>
+            </a:r>
+            <a:r>
+              <a:rPr lang="en-US" sz="1100" dirty="0"/>
+              <a:t> for production) by simply changing a configuration file, without altering any application code. </a:t>
+            </a:r>
+          </a:p>
+          <a:p>
+            <a:pPr>
+              <a:buNone/>
+            </a:pPr>
+            <a:r>
+              <a:rPr lang="en-US" sz="1100" dirty="0"/>
+              <a:t>2. Standardized Communication (</a:t>
+            </a:r>
+            <a:r>
+              <a:rPr lang="en-US" sz="1100" dirty="0" err="1"/>
+              <a:t>CloudEvents</a:t>
+            </a:r>
+            <a:r>
+              <a:rPr lang="en-US" sz="1100" dirty="0"/>
+              <a:t>)</a:t>
+            </a:r>
+          </a:p>
+          <a:p>
+            <a:pPr>
+              <a:buNone/>
+            </a:pPr>
+            <a:r>
+              <a:rPr lang="en-US" sz="1100" dirty="0" err="1"/>
+              <a:t>Dapr</a:t>
+            </a:r>
+            <a:r>
+              <a:rPr lang="en-US" sz="1100" dirty="0"/>
+              <a:t> automatically wraps outgoing messages in a standardized </a:t>
+            </a:r>
+            <a:r>
+              <a:rPr lang="en-US" sz="1100" b="1" dirty="0" err="1"/>
+              <a:t>CloudEvents</a:t>
+            </a:r>
+            <a:r>
+              <a:rPr lang="en-US" sz="1100" dirty="0"/>
+              <a:t> envelope. This ensures consistent metadata and formatting across all services, which simplifies cross-platform integration and event routing. </a:t>
+            </a:r>
+          </a:p>
+          <a:p>
+            <a:pPr>
+              <a:buNone/>
+            </a:pPr>
+            <a:r>
+              <a:rPr lang="en-US" sz="1100" dirty="0"/>
+              <a:t>3. Built-in Resiliency and Reliability </a:t>
+            </a:r>
+          </a:p>
+          <a:p>
+            <a:pPr>
+              <a:buNone/>
+            </a:pPr>
+            <a:r>
+              <a:rPr lang="en-US" sz="1100" dirty="0" err="1"/>
+              <a:t>Dapr</a:t>
+            </a:r>
+            <a:r>
+              <a:rPr lang="en-US" sz="1100" dirty="0"/>
+              <a:t> provides features that you would otherwise have to implement manually using a direct SDK: </a:t>
+            </a:r>
+          </a:p>
+          <a:p>
+            <a:pPr>
+              <a:buFont typeface="Arial" panose="020B0604020202020204" pitchFamily="34" charset="0"/>
+              <a:buChar char="•"/>
+            </a:pPr>
+            <a:r>
+              <a:rPr lang="en-US" sz="1100" b="1" dirty="0"/>
+              <a:t>At-least-once delivery:</a:t>
+            </a:r>
+            <a:r>
+              <a:rPr lang="en-US" sz="1100" dirty="0"/>
+              <a:t> </a:t>
+            </a:r>
+            <a:r>
+              <a:rPr lang="en-US" sz="1100" dirty="0" err="1"/>
+              <a:t>Dapr</a:t>
+            </a:r>
+            <a:r>
+              <a:rPr lang="en-US" sz="1100" dirty="0"/>
+              <a:t> guarantees messages reach subscribers even if the application or broker temporarily fails.</a:t>
+            </a:r>
+          </a:p>
+          <a:p>
+            <a:pPr>
+              <a:buFont typeface="Arial" panose="020B0604020202020204" pitchFamily="34" charset="0"/>
+              <a:buChar char="•"/>
+            </a:pPr>
+            <a:r>
+              <a:rPr lang="en-US" sz="1100" b="1" dirty="0"/>
+              <a:t>Automatic Retries:</a:t>
+            </a:r>
+            <a:r>
+              <a:rPr lang="en-US" sz="1100" dirty="0"/>
+              <a:t> </a:t>
+            </a:r>
+            <a:r>
+              <a:rPr lang="en-US" sz="1100" dirty="0" err="1"/>
+              <a:t>Dapr</a:t>
+            </a:r>
+            <a:r>
+              <a:rPr lang="en-US" sz="1100" dirty="0"/>
+              <a:t> handles retries for failed message deliveries based on configurable policies.</a:t>
+            </a:r>
+          </a:p>
+          <a:p>
+            <a:pPr>
+              <a:buFont typeface="Arial" panose="020B0604020202020204" pitchFamily="34" charset="0"/>
+              <a:buChar char="•"/>
+            </a:pPr>
+            <a:r>
+              <a:rPr lang="en-US" sz="1100" b="1" dirty="0"/>
+              <a:t>Competing Consumers:</a:t>
+            </a:r>
+            <a:r>
+              <a:rPr lang="en-US" sz="1100" dirty="0"/>
+              <a:t> </a:t>
+            </a:r>
+            <a:r>
+              <a:rPr lang="en-US" sz="1100" dirty="0" err="1"/>
+              <a:t>Dapr</a:t>
+            </a:r>
+            <a:r>
+              <a:rPr lang="en-US" sz="1100" dirty="0"/>
+              <a:t> manages consumer groups and ensures that only one instance of a scaled-out service processes a specific message. </a:t>
+            </a:r>
+          </a:p>
+          <a:p>
+            <a:pPr>
+              <a:buNone/>
+            </a:pPr>
+            <a:r>
+              <a:rPr lang="en-US" sz="1100" dirty="0"/>
+              <a:t>4. Reduced Code Complexity </a:t>
+            </a:r>
+          </a:p>
+          <a:p>
+            <a:pPr>
+              <a:buFont typeface="Arial" panose="020B0604020202020204" pitchFamily="34" charset="0"/>
+              <a:buChar char="•"/>
+            </a:pPr>
+            <a:r>
+              <a:rPr lang="en-US" sz="1100" b="1" dirty="0"/>
+              <a:t>Smaller SDK footprint:</a:t>
+            </a:r>
+            <a:r>
+              <a:rPr lang="en-US" sz="1100" dirty="0"/>
+              <a:t> By using </a:t>
+            </a:r>
+            <a:r>
+              <a:rPr lang="en-US" sz="1100" dirty="0" err="1"/>
+              <a:t>Dapr’s</a:t>
+            </a:r>
+            <a:r>
+              <a:rPr lang="en-US" sz="1100" dirty="0"/>
+              <a:t> HTTP or </a:t>
+            </a:r>
+            <a:r>
+              <a:rPr lang="en-US" sz="1100" dirty="0" err="1"/>
+              <a:t>gRPC</a:t>
+            </a:r>
+            <a:r>
+              <a:rPr lang="en-US" sz="1100" dirty="0"/>
+              <a:t> APIs, you avoid importing heavy, broker-specific SDKs into your code.</a:t>
+            </a:r>
+          </a:p>
+          <a:p>
+            <a:pPr>
+              <a:buFont typeface="Arial" panose="020B0604020202020204" pitchFamily="34" charset="0"/>
+              <a:buChar char="•"/>
+            </a:pPr>
+            <a:r>
+              <a:rPr lang="en-US" sz="1100" b="1" dirty="0"/>
+              <a:t>Simplified Subscriptions:</a:t>
+            </a:r>
+            <a:r>
+              <a:rPr lang="en-US" sz="1100" dirty="0"/>
+              <a:t> You can define subscriptions </a:t>
+            </a:r>
+            <a:r>
+              <a:rPr lang="en-US" sz="1100" b="1" dirty="0"/>
+              <a:t>declaratively</a:t>
+            </a:r>
+            <a:r>
+              <a:rPr lang="en-US" sz="1100" dirty="0"/>
+              <a:t> in YAML files rather than writing code to manage connection strings and listener loops.</a:t>
+            </a:r>
+          </a:p>
+          <a:p>
+            <a:pPr>
+              <a:buFont typeface="Arial" panose="020B0604020202020204" pitchFamily="34" charset="0"/>
+              <a:buChar char="•"/>
+            </a:pPr>
+            <a:r>
+              <a:rPr lang="en-US" sz="1100" b="1" dirty="0"/>
+              <a:t>Content-Based Routing:</a:t>
+            </a:r>
+            <a:r>
+              <a:rPr lang="en-US" sz="1100" dirty="0"/>
+              <a:t> </a:t>
+            </a:r>
+            <a:r>
+              <a:rPr lang="en-US" sz="1100" dirty="0" err="1"/>
+              <a:t>Dapr</a:t>
+            </a:r>
+            <a:r>
+              <a:rPr lang="en-US" sz="1100" dirty="0"/>
+              <a:t> allows you to route messages to different service endpoints based on the event's content without writing complex branching logic in your application. </a:t>
+            </a:r>
+          </a:p>
+          <a:p>
+            <a:pPr>
+              <a:buNone/>
+            </a:pPr>
+            <a:r>
+              <a:rPr lang="en-US" sz="1100" dirty="0"/>
+              <a:t>5. Enhanced Observability and Security </a:t>
+            </a:r>
+          </a:p>
+          <a:p>
+            <a:pPr>
+              <a:buFont typeface="Arial" panose="020B0604020202020204" pitchFamily="34" charset="0"/>
+              <a:buChar char="•"/>
+            </a:pPr>
+            <a:r>
+              <a:rPr lang="en-US" sz="1100" b="1" dirty="0"/>
+              <a:t>Tracing:</a:t>
+            </a:r>
+            <a:r>
+              <a:rPr lang="en-US" sz="1100" dirty="0"/>
+              <a:t> </a:t>
+            </a:r>
+            <a:r>
+              <a:rPr lang="en-US" sz="1100" dirty="0" err="1"/>
+              <a:t>Dapr</a:t>
+            </a:r>
+            <a:r>
+              <a:rPr lang="en-US" sz="1100" dirty="0"/>
+              <a:t> automatically injects trace headers, enabling end-to-end distributed tracing of messages through your entire system.</a:t>
+            </a:r>
+          </a:p>
+          <a:p>
+            <a:pPr>
+              <a:buFont typeface="Arial" panose="020B0604020202020204" pitchFamily="34" charset="0"/>
+              <a:buChar char="•"/>
+            </a:pPr>
+            <a:r>
+              <a:rPr lang="en-US" sz="1100" b="1" dirty="0"/>
+              <a:t>Scoped Access:</a:t>
+            </a:r>
+            <a:r>
+              <a:rPr lang="en-US" sz="1100" dirty="0"/>
+              <a:t> You can use </a:t>
+            </a:r>
+            <a:r>
+              <a:rPr lang="en-US" sz="1100" dirty="0" err="1"/>
+              <a:t>Dapr</a:t>
+            </a:r>
+            <a:r>
+              <a:rPr lang="en-US" sz="1100" dirty="0"/>
+              <a:t> components to strictly control which applications are permitted to publish or subscribe to specific topics. </a:t>
+            </a:r>
+          </a:p>
+        </p:txBody>
+      </p:sp>
+    </p:spTree>
+    <p:extLst>
+      <p:ext uri="{BB962C8B-B14F-4D97-AF65-F5344CB8AC3E}">
+        <p14:creationId xmlns:p14="http://schemas.microsoft.com/office/powerpoint/2010/main" val="1678035857"/>
+      </p:ext>
+    </p:extLst>
+  </p:cSld>
+  <p:clrMapOvr>
+    <a:masterClrMapping/>
+  </p:clrMapOvr>
+</p:sld>
+</file>
+
+<file path=ppt/slides/slide3.xml><?xml version="1.0" encoding="utf-8"?>
 <p:sld xmlns:a="http://schemas.openxmlformats.org/drawingml/2006/main" xmlns:r="http://schemas.openxmlformats.org/officeDocument/2006/relationships" xmlns:p="http://schemas.openxmlformats.org/presentationml/2006/main">
   <p:cSld>
     <p:bg>
@@ -4075,14 +4535,30 @@
           <a:lstStyle/>
           <a:p>
             <a:r>
-              <a:rPr lang="en-US" sz="1100">
+              <a:rPr lang="en-US" sz="1100" dirty="0">
                 <a:solidFill>
                   <a:srgbClr val="8CFFBE"/>
                 </a:solidFill>
               </a:rPr>
-              <a:t>Zero lines — Dapr sidecar owns the connection entirely</a:t>
-            </a:r>
-            <a:endParaRPr lang="ru-RU" sz="1100">
+              <a:t>Zero lines — </a:t>
+            </a:r>
+            <a:r>
+              <a:rPr lang="en-US" sz="1100" dirty="0" err="1">
+                <a:solidFill>
+                  <a:srgbClr val="8CFFBE"/>
+                </a:solidFill>
+              </a:rPr>
+              <a:t>Dapr</a:t>
+            </a:r>
+            <a:r>
+              <a:rPr lang="en-US" sz="1100" dirty="0">
+                <a:solidFill>
+                  <a:srgbClr val="8CFFBE"/>
+                </a:solidFill>
+              </a:rPr>
+              <a:t> sidecar owns the connection entirely</a:t>
+            </a:r>
+            <a:endParaRPr lang="ru-RU" sz="1100" dirty="0">
               <a:solidFill>
                 <a:srgbClr val="8CFFBE"/>
               </a:solidFill>
@@ -4211,14 +4687,14 @@
           <a:lstStyle/>
           <a:p>
             <a:r>
-              <a:rPr lang="nb-NO" sz="1100">
+              <a:rPr lang="nb-NO" sz="1100" dirty="0">
                 <a:solidFill>
                   <a:srgbClr val="8CFFBE"/>
                 </a:solidFill>
               </a:rPr>
               <a:t>YAML component swap — RabbitMQ, Kafka, Redis Streams; app code unchanged</a:t>
             </a:r>
-            <a:endParaRPr lang="ru-RU" sz="1100">
+            <a:endParaRPr lang="ru-RU" sz="1100" dirty="0">
               <a:solidFill>
                 <a:srgbClr val="8CFFBE"/>
               </a:solidFill>
@@ -4347,14 +4823,38 @@
           <a:lstStyle/>
           <a:p>
             <a:r>
-              <a:rPr lang="en-US" sz="1100">
+              <a:rPr lang="en-US" sz="1100" dirty="0" err="1">
                 <a:solidFill>
                   <a:srgbClr val="8CFFBE"/>
                 </a:solidFill>
               </a:rPr>
-              <a:t>requireSessions: "true" in subscription.yaml — one config line</a:t>
-            </a:r>
-            <a:endParaRPr lang="ru-RU" sz="1100">
+              <a:t>requireSessions</a:t>
+            </a:r>
+            <a:r>
+              <a:rPr lang="en-US" sz="1100" dirty="0">
+                <a:solidFill>
+                  <a:srgbClr val="8CFFBE"/>
+                </a:solidFill>
+              </a:rPr>
+              <a:t>: "true" in </a:t>
+            </a:r>
+            <a:r>
+              <a:rPr lang="en-US" sz="1100" dirty="0" err="1">
+                <a:solidFill>
+                  <a:srgbClr val="8CFFBE"/>
+                </a:solidFill>
+              </a:rPr>
+              <a:t>subscription.yaml</a:t>
+            </a:r>
+            <a:r>
+              <a:rPr lang="en-US" sz="1100" dirty="0">
+                <a:solidFill>
+                  <a:srgbClr val="8CFFBE"/>
+                </a:solidFill>
+              </a:rPr>
+              <a:t> — one config line</a:t>
+            </a:r>
+            <a:endParaRPr lang="ru-RU" sz="1100" dirty="0">
               <a:solidFill>
                 <a:srgbClr val="8CFFBE"/>
               </a:solidFill>
@@ -4625,142 +5125,6 @@
                 </a:solidFill>
               </a:rPr>
               <a:t>W3C trace context propagated automatically; OpenTelemetry export built in</a:t>
-            </a:r>
-            <a:endParaRPr lang="ru-RU" sz="1100">
-              <a:solidFill>
-                <a:srgbClr val="8CFFBE"/>
-              </a:solidFill>
-            </a:endParaRPr>
-          </a:p>
-        </p:txBody>
-      </p:sp>
-      <p:sp>
-        <p:nvSpPr>
-          <p:cNvPr id="21" name="TextBox 20">
-            <a:extLst>
-              <a:ext uri="{FF2B5EF4-FFF2-40B4-BE49-F238E27FC236}">
-                <a16:creationId xmlns:a16="http://schemas.microsoft.com/office/drawing/2014/main" id="{C488D8C7-6C0C-FFC7-FD14-AD684113A69A}"/>
-              </a:ext>
-            </a:extLst>
-          </p:cNvPr>
-          <p:cNvSpPr txBox="1"/>
-          <p:nvPr/>
-        </p:nvSpPr>
-        <p:spPr>
-          <a:xfrm>
-            <a:off x="698500" y="5727700"/>
-            <a:ext cx="10922000" cy="261610"/>
-          </a:xfrm>
-          <a:prstGeom prst="rect">
-            <a:avLst/>
-          </a:prstGeom>
-          <a:noFill/>
-        </p:spPr>
-        <p:txBody>
-          <a:bodyPr vert="horz" wrap="square" rtlCol="0">
-            <a:spAutoFit/>
-          </a:bodyPr>
-          <a:lstStyle/>
-          <a:p>
-            <a:r>
-              <a:rPr lang="nb-NO" sz="1100" b="1">
-                <a:solidFill>
-                  <a:srgbClr val="A0AFC8"/>
-                </a:solidFill>
-              </a:rPr>
-              <a:t>Local development</a:t>
-            </a:r>
-            <a:endParaRPr lang="ru-RU" sz="1100" b="1">
-              <a:solidFill>
-                <a:srgbClr val="A0AFC8"/>
-              </a:solidFill>
-            </a:endParaRPr>
-          </a:p>
-        </p:txBody>
-      </p:sp>
-      <p:sp>
-        <p:nvSpPr>
-          <p:cNvPr id="22" name="TextBox 21">
-            <a:extLst>
-              <a:ext uri="{FF2B5EF4-FFF2-40B4-BE49-F238E27FC236}">
-                <a16:creationId xmlns:a16="http://schemas.microsoft.com/office/drawing/2014/main" id="{C04EDEE8-6E89-7F3F-87F2-2D09E7B19CA3}"/>
-              </a:ext>
-            </a:extLst>
-          </p:cNvPr>
-          <p:cNvSpPr txBox="1"/>
-          <p:nvPr/>
-        </p:nvSpPr>
-        <p:spPr>
-          <a:xfrm>
-            <a:off x="698500" y="5943600"/>
-            <a:ext cx="5270500" cy="261610"/>
-          </a:xfrm>
-          <a:prstGeom prst="rect">
-            <a:avLst/>
-          </a:prstGeom>
-          <a:solidFill>
-            <a:srgbClr val="32230F"/>
-          </a:solidFill>
-        </p:spPr>
-        <p:txBody>
-          <a:bodyPr vert="horz" wrap="square" rtlCol="0">
-            <a:spAutoFit/>
-          </a:bodyPr>
-          <a:lstStyle/>
-          <a:p>
-            <a:r>
-              <a:rPr lang="en-US" sz="1100">
-                <a:solidFill>
-                  <a:srgbClr val="FFC88C"/>
-                </a:solidFill>
-              </a:rPr>
-              <a:t>Needs real ASB namespace or complex mocking; high setup friction</a:t>
-            </a:r>
-            <a:endParaRPr lang="ru-RU" sz="1100">
-              <a:solidFill>
-                <a:srgbClr val="FFC88C"/>
-              </a:solidFill>
-            </a:endParaRPr>
-          </a:p>
-        </p:txBody>
-      </p:sp>
-      <p:sp>
-        <p:nvSpPr>
-          <p:cNvPr id="23" name="TextBox 22">
-            <a:extLst>
-              <a:ext uri="{FF2B5EF4-FFF2-40B4-BE49-F238E27FC236}">
-                <a16:creationId xmlns:a16="http://schemas.microsoft.com/office/drawing/2014/main" id="{447F04FE-1A01-7BFC-FF56-474AC256A13D}"/>
-              </a:ext>
-            </a:extLst>
-          </p:cNvPr>
-          <p:cNvSpPr txBox="1"/>
-          <p:nvPr/>
-        </p:nvSpPr>
-        <p:spPr>
-          <a:xfrm>
-            <a:off x="6096000" y="5943600"/>
-            <a:ext cx="5397500" cy="261610"/>
-          </a:xfrm>
-          <a:prstGeom prst="rect">
-            <a:avLst/>
-          </a:prstGeom>
-          <a:solidFill>
-            <a:srgbClr val="0A2D19"/>
-          </a:solidFill>
-        </p:spPr>
-        <p:txBody>
-          <a:bodyPr vert="horz" wrap="square" rtlCol="0">
-            <a:spAutoFit/>
-          </a:bodyPr>
-          <a:lstStyle/>
-          <a:p>
-            <a:r>
-              <a:rPr lang="en-US" sz="1100">
-                <a:solidFill>
-                  <a:srgbClr val="8CFFBE"/>
-                </a:solidFill>
-              </a:rPr>
-              <a:t>Local emulator, any broker via component swap; works fully offline</a:t>
             </a:r>
             <a:endParaRPr lang="ru-RU" sz="1100">
               <a:solidFill>
@@ -4783,7 +5147,7 @@
 </p:sld>
 </file>
 
-<file path=ppt/slides/slide3.xml><?xml version="1.0" encoding="utf-8"?>
+<file path=ppt/slides/slide4.xml><?xml version="1.0" encoding="utf-8"?>
 <p:sld xmlns:a="http://schemas.openxmlformats.org/drawingml/2006/main" xmlns:r="http://schemas.openxmlformats.org/officeDocument/2006/relationships" xmlns:p="http://schemas.openxmlformats.org/presentationml/2006/main">
   <p:cSld>
     <p:bg>

</xml_diff>